<commit_message>
fix(pptx): stretch textPlain WordArt to fill its shape
The textPlain text warp ("Square" in the PowerPoint Transform gallery) was treated as no warp, so its text rendered as an ordinary wrapped paragraph. A word wider than its shape then broke a letter or two per line, where PowerPoint squeezes it onto one line that fills the shape.

Its preset paths are straight lines along the box's top and bottom edges, so it belongs to the two-curve envelope family. It now renders through the glyph envelope in every binding, from the guide formulas in presetTextWarpDefinitions.xml. Away from the default adj those formulas shorten the top path at one end and the bottom path at the other, so each envelope curve can now span part of the width.

The text-warp-fidelity fixture used textPlain as its no-warp control; that control is now textNoShape, and a textPlain shape holding a word wider than its small square box is added, with an e2e check that its glyphs fill the box in all five bindings.
</commit_message>
<xml_diff>
--- a/e2e/pptx/fixtures/text-warp-fidelity.pptx
+++ b/e2e/pptx/fixtures/text-warp-fidelity.pptx
@@ -344,7 +344,7 @@
         </p:spPr>
         <p:txBody>
           <a:bodyPr wrap="none">
-            <a:prstTxWarp prst="textPlain">
+            <a:prstTxWarp prst="textNoShape">
               <a:avLst/>
             </a:prstTxWarp>
           </a:bodyPr>
@@ -447,6 +447,43 @@
                 <a:latin typeface="PptxE2EWideGlyphNoOutlineMatch"/>
               </a:rPr>
               <a:t>MOM</a:t>
+            </a:r>
+          </a:p>
+        </p:txBody>
+      </p:sp>
+      <p:sp>
+        <p:nvSpPr>
+          <p:cNvPr id="12" name="plain"/>
+          <p:cNvSpPr txBox="1"/>
+          <p:nvPr/>
+        </p:nvSpPr>
+        <p:spPr>
+          <a:xfrm>
+            <a:off x="3302000" y="3810000"/>
+            <a:ext cx="508000" cy="508000"/>
+          </a:xfrm>
+          <a:prstGeom prst="rect">
+            <a:avLst/>
+          </a:prstGeom>
+          <a:noFill/>
+        </p:spPr>
+        <p:txBody>
+          <a:bodyPr wrap="none">
+            <a:prstTxWarp prst="textPlain">
+              <a:avLst/>
+            </a:prstTxWarp>
+          </a:bodyPr>
+          <a:lstStyle/>
+          <a:p>
+            <a:pPr algn="ctr"/>
+            <a:r>
+              <a:rPr lang="en-US" sz="1400" b="1">
+                <a:solidFill>
+                  <a:srgbClr val="2E75B6"/>
+                </a:solidFill>
+                <a:latin typeface="Arial"/>
+              </a:rPr>
+              <a:t>schedule</a:t>
             </a:r>
           </a:p>
         </p:txBody>

</xml_diff>